<commit_message>
Deploying to gh-pages from @ nlmixr2/monolix2rx@ca1ffea087e2a48ffbafe9e758e59bf7f8efa59a 🚀
</commit_message>
<xml_diff>
--- a/articles/mod-PowerPoint.pptx
+++ b/articles/mod-PowerPoint.pptx
@@ -3699,7 +3699,7 @@
                         <a:buNone/>
                       </a:pPr>
                       <a:r>
-                        <a:rPr cap="none" sz="1100" i="0" b="0" u="none">
+                        <a:rPr cap="none" sz="1100" i="0" b="0" u="none" strike="noStrike">
                           <a:solidFill>
                             <a:srgbClr val="000000">
                               <a:alpha val="100000"/>
@@ -3764,7 +3764,7 @@
                         <a:buNone/>
                       </a:pPr>
                       <a:r>
-                        <a:rPr cap="none" sz="1100" i="0" b="0" u="none">
+                        <a:rPr cap="none" sz="1100" i="0" b="0" u="none" strike="noStrike">
                           <a:solidFill>
                             <a:srgbClr val="000000">
                               <a:alpha val="100000"/>
@@ -3829,7 +3829,7 @@
                         <a:buNone/>
                       </a:pPr>
                       <a:r>
-                        <a:rPr cap="none" sz="1100" i="0" b="0" u="none">
+                        <a:rPr cap="none" sz="1100" i="0" b="0" u="none" strike="noStrike">
                           <a:solidFill>
                             <a:srgbClr val="000000">
                               <a:alpha val="100000"/>
@@ -3894,7 +3894,7 @@
                         <a:buNone/>
                       </a:pPr>
                       <a:r>
-                        <a:rPr cap="none" sz="1100" i="0" b="0" u="none">
+                        <a:rPr cap="none" sz="1100" i="0" b="0" u="none" strike="noStrike">
                           <a:solidFill>
                             <a:srgbClr val="000000">
                               <a:alpha val="100000"/>
@@ -3959,7 +3959,7 @@
                         <a:buNone/>
                       </a:pPr>
                       <a:r>
-                        <a:rPr cap="none" sz="1100" i="0" b="0" u="none">
+                        <a:rPr cap="none" sz="1100" i="0" b="0" u="none" strike="noStrike">
                           <a:solidFill>
                             <a:srgbClr val="000000">
                               <a:alpha val="100000"/>
@@ -4024,7 +4024,7 @@
                         <a:buNone/>
                       </a:pPr>
                       <a:r>
-                        <a:rPr cap="none" sz="1100" i="0" b="0" u="none">
+                        <a:rPr cap="none" sz="1100" i="0" b="0" u="none" strike="noStrike">
                           <a:solidFill>
                             <a:srgbClr val="000000">
                               <a:alpha val="100000"/>
@@ -4089,7 +4089,7 @@
                         <a:buNone/>
                       </a:pPr>
                       <a:r>
-                        <a:rPr cap="none" sz="1100" i="0" b="0" u="none">
+                        <a:rPr cap="none" sz="1100" i="0" b="0" u="none" strike="noStrike">
                           <a:solidFill>
                             <a:srgbClr val="000000">
                               <a:alpha val="100000"/>
@@ -4156,7 +4156,7 @@
                         <a:buNone/>
                       </a:pPr>
                       <a:r>
-                        <a:rPr cap="none" sz="1200" i="0" b="0" u="none">
+                        <a:rPr cap="none" sz="1200" i="0" b="0" u="none" strike="noStrike">
                           <a:solidFill>
                             <a:srgbClr val="000000">
                               <a:alpha val="100000"/>
@@ -4213,7 +4213,7 @@
                         <a:buNone/>
                       </a:pPr>
                       <a:r>
-                        <a:rPr cap="none" sz="1100" i="0" b="0" u="none">
+                        <a:rPr cap="none" sz="1100" i="0" b="0" u="none" strike="noStrike">
                           <a:solidFill>
                             <a:srgbClr val="000000">
                               <a:alpha val="100000"/>
@@ -4270,7 +4270,7 @@
                         <a:buNone/>
                       </a:pPr>
                       <a:r>
-                        <a:rPr cap="none" sz="1100" i="0" b="0" u="none">
+                        <a:rPr cap="none" sz="1100" i="0" b="0" u="none" strike="noStrike">
                           <a:solidFill>
                             <a:srgbClr val="000000">
                               <a:alpha val="100000"/>
@@ -4327,7 +4327,7 @@
                         <a:buNone/>
                       </a:pPr>
                       <a:r>
-                        <a:rPr cap="none" sz="1100" i="0" b="0" u="none">
+                        <a:rPr cap="none" sz="1100" i="0" b="0" u="none" strike="noStrike">
                           <a:solidFill>
                             <a:srgbClr val="000000">
                               <a:alpha val="100000"/>
@@ -4384,7 +4384,7 @@
                         <a:buNone/>
                       </a:pPr>
                       <a:r>
-                        <a:rPr cap="none" sz="1100" i="0" b="0" u="none">
+                        <a:rPr cap="none" sz="1100" i="0" b="0" u="none" strike="noStrike">
                           <a:solidFill>
                             <a:srgbClr val="000000">
                               <a:alpha val="100000"/>
@@ -4441,7 +4441,7 @@
                         <a:buNone/>
                       </a:pPr>
                       <a:r>
-                        <a:rPr cap="none" sz="1100" i="0" b="0" u="none">
+                        <a:rPr cap="none" sz="1100" i="0" b="0" u="none" strike="noStrike">
                           <a:solidFill>
                             <a:srgbClr val="000000">
                               <a:alpha val="100000"/>
@@ -4498,7 +4498,7 @@
                         <a:buNone/>
                       </a:pPr>
                       <a:r>
-                        <a:rPr cap="none" sz="1100" i="0" b="0" u="none">
+                        <a:rPr cap="none" sz="1100" i="0" b="0" u="none" strike="noStrike">
                           <a:solidFill>
                             <a:srgbClr val="000000">
                               <a:alpha val="100000"/>
@@ -4557,7 +4557,7 @@
                         <a:buNone/>
                       </a:pPr>
                       <a:r>
-                        <a:rPr cap="none" sz="1200" i="0" b="0" u="none">
+                        <a:rPr cap="none" sz="1200" i="0" b="0" u="none" strike="noStrike">
                           <a:solidFill>
                             <a:srgbClr val="000000">
                               <a:alpha val="100000"/>
@@ -4614,7 +4614,7 @@
                         <a:buNone/>
                       </a:pPr>
                       <a:r>
-                        <a:rPr cap="none" sz="1100" i="0" b="0" u="none">
+                        <a:rPr cap="none" sz="1100" i="0" b="0" u="none" strike="noStrike">
                           <a:solidFill>
                             <a:srgbClr val="000000">
                               <a:alpha val="100000"/>
@@ -4671,7 +4671,7 @@
                         <a:buNone/>
                       </a:pPr>
                       <a:r>
-                        <a:rPr cap="none" sz="1100" i="0" b="0" u="none">
+                        <a:rPr cap="none" sz="1100" i="0" b="0" u="none" strike="noStrike">
                           <a:solidFill>
                             <a:srgbClr val="000000">
                               <a:alpha val="100000"/>
@@ -4728,7 +4728,7 @@
                         <a:buNone/>
                       </a:pPr>
                       <a:r>
-                        <a:rPr cap="none" sz="1100" i="0" b="0" u="none">
+                        <a:rPr cap="none" sz="1100" i="0" b="0" u="none" strike="noStrike">
                           <a:solidFill>
                             <a:srgbClr val="000000">
                               <a:alpha val="100000"/>
@@ -4785,7 +4785,7 @@
                         <a:buNone/>
                       </a:pPr>
                       <a:r>
-                        <a:rPr cap="none" sz="1100" i="0" b="0" u="none">
+                        <a:rPr cap="none" sz="1100" i="0" b="0" u="none" strike="noStrike">
                           <a:solidFill>
                             <a:srgbClr val="000000">
                               <a:alpha val="100000"/>
@@ -4842,7 +4842,7 @@
                         <a:buNone/>
                       </a:pPr>
                       <a:r>
-                        <a:rPr cap="none" sz="1100" i="0" b="0" u="none">
+                        <a:rPr cap="none" sz="1100" i="0" b="0" u="none" strike="noStrike">
                           <a:solidFill>
                             <a:srgbClr val="000000">
                               <a:alpha val="100000"/>
@@ -4899,7 +4899,7 @@
                         <a:buNone/>
                       </a:pPr>
                       <a:r>
-                        <a:rPr cap="none" sz="1100" i="0" b="0" u="none">
+                        <a:rPr cap="none" sz="1100" i="0" b="0" u="none" strike="noStrike">
                           <a:solidFill>
                             <a:srgbClr val="000000">
                               <a:alpha val="100000"/>
@@ -4958,7 +4958,7 @@
                         <a:buNone/>
                       </a:pPr>
                       <a:r>
-                        <a:rPr cap="none" sz="1200" i="0" b="0" u="none">
+                        <a:rPr cap="none" sz="1200" i="0" b="0" u="none" strike="noStrike">
                           <a:solidFill>
                             <a:srgbClr val="000000">
                               <a:alpha val="100000"/>
@@ -5015,7 +5015,7 @@
                         <a:buNone/>
                       </a:pPr>
                       <a:r>
-                        <a:rPr cap="none" sz="1100" i="0" b="0" u="none">
+                        <a:rPr cap="none" sz="1100" i="0" b="0" u="none" strike="noStrike">
                           <a:solidFill>
                             <a:srgbClr val="000000">
                               <a:alpha val="100000"/>
@@ -5072,7 +5072,7 @@
                         <a:buNone/>
                       </a:pPr>
                       <a:r>
-                        <a:rPr cap="none" sz="1100" i="0" b="0" u="none">
+                        <a:rPr cap="none" sz="1100" i="0" b="0" u="none" strike="noStrike">
                           <a:solidFill>
                             <a:srgbClr val="000000">
                               <a:alpha val="100000"/>
@@ -5129,7 +5129,7 @@
                         <a:buNone/>
                       </a:pPr>
                       <a:r>
-                        <a:rPr cap="none" sz="1100" i="0" b="0" u="none">
+                        <a:rPr cap="none" sz="1100" i="0" b="0" u="none" strike="noStrike">
                           <a:solidFill>
                             <a:srgbClr val="000000">
                               <a:alpha val="100000"/>
@@ -5186,7 +5186,7 @@
                         <a:buNone/>
                       </a:pPr>
                       <a:r>
-                        <a:rPr cap="none" sz="1100" i="0" b="0" u="none">
+                        <a:rPr cap="none" sz="1100" i="0" b="0" u="none" strike="noStrike">
                           <a:solidFill>
                             <a:srgbClr val="000000">
                               <a:alpha val="100000"/>
@@ -5243,7 +5243,7 @@
                         <a:buNone/>
                       </a:pPr>
                       <a:r>
-                        <a:rPr cap="none" sz="1100" i="0" b="0" u="none">
+                        <a:rPr cap="none" sz="1100" i="0" b="0" u="none" strike="noStrike">
                           <a:solidFill>
                             <a:srgbClr val="000000">
                               <a:alpha val="100000"/>
@@ -5300,7 +5300,7 @@
                         <a:buNone/>
                       </a:pPr>
                       <a:r>
-                        <a:rPr cap="none" sz="1100" i="0" b="0" u="none">
+                        <a:rPr cap="none" sz="1100" i="0" b="0" u="none" strike="noStrike">
                           <a:solidFill>
                             <a:srgbClr val="000000">
                               <a:alpha val="100000"/>
@@ -5359,7 +5359,7 @@
                         <a:buNone/>
                       </a:pPr>
                       <a:r>
-                        <a:rPr cap="none" sz="1200" i="0" b="0" u="none">
+                        <a:rPr cap="none" sz="1200" i="0" b="0" u="none" strike="noStrike">
                           <a:solidFill>
                             <a:srgbClr val="000000">
                               <a:alpha val="100000"/>
@@ -5416,7 +5416,7 @@
                         <a:buNone/>
                       </a:pPr>
                       <a:r>
-                        <a:rPr cap="none" sz="1100" i="0" b="0" u="none">
+                        <a:rPr cap="none" sz="1100" i="0" b="0" u="none" strike="noStrike">
                           <a:solidFill>
                             <a:srgbClr val="000000">
                               <a:alpha val="100000"/>
@@ -5472,7 +5472,7 @@
                         </a:spcAft>
                         <a:buNone/>
                       </a:pPr>
-                      <a:endParaRPr cap="none" sz="1100" i="0" b="0" u="none">
+                      <a:endParaRPr cap="none" sz="1100" i="0" b="0" u="none" strike="noStrike">
                         <a:solidFill>
                           <a:srgbClr val="000000">
                             <a:alpha val="100000"/>
@@ -5484,7 +5484,7 @@
                         <a:sym typeface="DejaVu Sans"/>
                       </a:endParaRPr>
                       <a:r>
-                        <a:rPr cap="none" sz="1100" i="0" b="0" u="none">
+                        <a:rPr cap="none" sz="1100" i="0" b="0" u="none" strike="noStrike">
                           <a:solidFill>
                             <a:srgbClr val="000000">
                               <a:alpha val="100000"/>
@@ -5540,7 +5540,7 @@
                         </a:spcAft>
                         <a:buNone/>
                       </a:pPr>
-                      <a:endParaRPr cap="none" sz="1100" i="0" b="0" u="none">
+                      <a:endParaRPr cap="none" sz="1100" i="0" b="0" u="none" strike="noStrike">
                         <a:solidFill>
                           <a:srgbClr val="000000">
                             <a:alpha val="100000"/>
@@ -5552,7 +5552,7 @@
                         <a:sym typeface="DejaVu Sans"/>
                       </a:endParaRPr>
                       <a:r>
-                        <a:rPr cap="none" sz="1100" i="0" b="0" u="none">
+                        <a:rPr cap="none" sz="1100" i="0" b="0" u="none" strike="noStrike">
                           <a:solidFill>
                             <a:srgbClr val="000000">
                               <a:alpha val="100000"/>
@@ -5609,7 +5609,7 @@
                         <a:buNone/>
                       </a:pPr>
                       <a:r>
-                        <a:rPr cap="none" sz="1100" i="0" b="0" u="none">
+                        <a:rPr cap="none" sz="1100" i="0" b="0" u="none" strike="noStrike">
                           <a:solidFill>
                             <a:srgbClr val="000000">
                               <a:alpha val="100000"/>
@@ -5666,7 +5666,7 @@
                         <a:buNone/>
                       </a:pPr>
                       <a:r>
-                        <a:rPr cap="none" sz="1100" i="0" b="0" u="none">
+                        <a:rPr cap="none" sz="1100" i="0" b="0" u="none" strike="noStrike">
                           <a:solidFill>
                             <a:srgbClr val="000000">
                               <a:alpha val="100000"/>
@@ -5723,7 +5723,7 @@
                         <a:buNone/>
                       </a:pPr>
                       <a:r>
-                        <a:rPr cap="none" sz="1100" i="0" b="0" u="none">
+                        <a:rPr cap="none" sz="1100" i="0" b="0" u="none" strike="noStrike">
                           <a:solidFill>
                             <a:srgbClr val="000000">
                               <a:alpha val="100000"/>
@@ -5782,7 +5782,7 @@
                         <a:buNone/>
                       </a:pPr>
                       <a:r>
-                        <a:rPr cap="none" sz="1200" i="0" b="0" u="none">
+                        <a:rPr cap="none" sz="1200" i="0" b="0" u="none" strike="noStrike">
                           <a:solidFill>
                             <a:srgbClr val="000000">
                               <a:alpha val="100000"/>
@@ -5843,7 +5843,7 @@
                         <a:buNone/>
                       </a:pPr>
                       <a:r>
-                        <a:rPr cap="none" sz="1100" i="0" b="0" u="none">
+                        <a:rPr cap="none" sz="1100" i="0" b="0" u="none" strike="noStrike">
                           <a:solidFill>
                             <a:srgbClr val="000000">
                               <a:alpha val="100000"/>
@@ -5903,7 +5903,7 @@
                         </a:spcAft>
                         <a:buNone/>
                       </a:pPr>
-                      <a:endParaRPr cap="none" sz="1100" i="0" b="0" u="none">
+                      <a:endParaRPr cap="none" sz="1100" i="0" b="0" u="none" strike="noStrike">
                         <a:solidFill>
                           <a:srgbClr val="000000">
                             <a:alpha val="100000"/>
@@ -5915,7 +5915,7 @@
                         <a:sym typeface="DejaVu Sans"/>
                       </a:endParaRPr>
                       <a:r>
-                        <a:rPr cap="none" sz="1100" i="0" b="0" u="none">
+                        <a:rPr cap="none" sz="1100" i="0" b="0" u="none" strike="noStrike">
                           <a:solidFill>
                             <a:srgbClr val="000000">
                               <a:alpha val="100000"/>
@@ -5975,7 +5975,7 @@
                         </a:spcAft>
                         <a:buNone/>
                       </a:pPr>
-                      <a:endParaRPr cap="none" sz="1100" i="0" b="0" u="none">
+                      <a:endParaRPr cap="none" sz="1100" i="0" b="0" u="none" strike="noStrike">
                         <a:solidFill>
                           <a:srgbClr val="000000">
                             <a:alpha val="100000"/>
@@ -5987,7 +5987,7 @@
                         <a:sym typeface="DejaVu Sans"/>
                       </a:endParaRPr>
                       <a:r>
-                        <a:rPr cap="none" sz="1100" i="0" b="0" u="none">
+                        <a:rPr cap="none" sz="1100" i="0" b="0" u="none" strike="noStrike">
                           <a:solidFill>
                             <a:srgbClr val="000000">
                               <a:alpha val="100000"/>
@@ -6048,7 +6048,7 @@
                         <a:buNone/>
                       </a:pPr>
                       <a:r>
-                        <a:rPr cap="none" sz="1100" i="0" b="0" u="none">
+                        <a:rPr cap="none" sz="1100" i="0" b="0" u="none" strike="noStrike">
                           <a:solidFill>
                             <a:srgbClr val="000000">
                               <a:alpha val="100000"/>
@@ -6109,7 +6109,7 @@
                         <a:buNone/>
                       </a:pPr>
                       <a:r>
-                        <a:rPr cap="none" sz="1100" i="0" b="0" u="none">
+                        <a:rPr cap="none" sz="1100" i="0" b="0" u="none" strike="noStrike">
                           <a:solidFill>
                             <a:srgbClr val="000000">
                               <a:alpha val="100000"/>
@@ -6170,7 +6170,7 @@
                         <a:buNone/>
                       </a:pPr>
                       <a:r>
-                        <a:rPr cap="none" sz="1100" i="0" b="0" u="none">
+                        <a:rPr cap="none" sz="1100" i="0" b="0" u="none" strike="noStrike">
                           <a:solidFill>
                             <a:srgbClr val="000000">
                               <a:alpha val="100000"/>

</xml_diff>

<commit_message>
Deploying to gh-pages from @ nlmixr2/monolix2rx@99c640b21d3cee9ed75bcdf0442053b6bc7b2df3 🚀
</commit_message>
<xml_diff>
--- a/articles/mod-PowerPoint.pptx
+++ b/articles/mod-PowerPoint.pptx
@@ -3673,14 +3673,14 @@
               <a:tblPr/>
               <a:tblGrid>
                 <a:gridCol w="993857"/>
-                <a:gridCol w="749587"/>
-                <a:gridCol w="749587"/>
-                <a:gridCol w="667527"/>
-                <a:gridCol w="2070530"/>
+                <a:gridCol w="838468"/>
+                <a:gridCol w="1063707"/>
+                <a:gridCol w="1063707"/>
+                <a:gridCol w="2236082"/>
                 <a:gridCol w="975713"/>
                 <a:gridCol w="1141675"/>
               </a:tblGrid>
-              <a:tr h="385330">
+              <a:tr h="405130">
                 <a:tc>
                   <a:txBody>
                     <a:bodyPr/>
@@ -4137,7 +4137,7 @@
                   </a:tcPr>
                 </a:tc>
               </a:tr>
-              <a:tr h="405096">
+              <a:tr h="401320">
                 <a:tc>
                   <a:txBody>
                     <a:bodyPr/>
@@ -4224,7 +4224,7 @@
                           <a:ea typeface="DejaVu Sans"/>
                           <a:sym typeface="DejaVu Sans"/>
                         </a:rPr>
-                        <a:t>0.427</a:t>
+                        <a:t>0.4270</a:t>
                       </a:r>
                     </a:p>
                   </a:txBody>
@@ -4281,7 +4281,7 @@
                           <a:ea typeface="DejaVu Sans"/>
                           <a:sym typeface="DejaVu Sans"/>
                         </a:rPr>
-                        <a:t>0.204</a:t>
+                        <a:t>0.2041</a:t>
                       </a:r>
                     </a:p>
                   </a:txBody>
@@ -4338,7 +4338,7 @@
                           <a:ea typeface="DejaVu Sans"/>
                           <a:sym typeface="DejaVu Sans"/>
                         </a:rPr>
-                        <a:t>47.8</a:t>
+                        <a:t>47.80</a:t>
                       </a:r>
                     </a:p>
                   </a:txBody>
@@ -4395,7 +4395,7 @@
                           <a:ea typeface="DejaVu Sans"/>
                           <a:sym typeface="DejaVu Sans"/>
                         </a:rPr>
-                        <a:t>1.53 (1.03, 2.29)</a:t>
+                        <a:t>1.533 (1.027, 2.286)</a:t>
                       </a:r>
                     </a:p>
                   </a:txBody>
@@ -4452,7 +4452,7 @@
                           <a:ea typeface="DejaVu Sans"/>
                           <a:sym typeface="DejaVu Sans"/>
                         </a:rPr>
-                        <a:t>75.4</a:t>
+                        <a:t>75.42</a:t>
                       </a:r>
                     </a:p>
                   </a:txBody>
@@ -4509,7 +4509,7 @@
                           <a:ea typeface="DejaVu Sans"/>
                           <a:sym typeface="DejaVu Sans"/>
                         </a:rPr>
-                        <a:t>1.05%&lt;</a:t>
+                        <a:t>1.055&lt;</a:t>
                       </a:r>
                     </a:p>
                   </a:txBody>
@@ -4538,7 +4538,7 @@
                   </a:tcPr>
                 </a:tc>
               </a:tr>
-              <a:tr h="405096">
+              <a:tr h="401320">
                 <a:tc>
                   <a:txBody>
                     <a:bodyPr/>
@@ -4625,7 +4625,7 @@
                           <a:ea typeface="DejaVu Sans"/>
                           <a:sym typeface="DejaVu Sans"/>
                         </a:rPr>
-                        <a:t>-0.786</a:t>
+                        <a:t>-0.7864</a:t>
                       </a:r>
                     </a:p>
                   </a:txBody>
@@ -4682,7 +4682,7 @@
                           <a:ea typeface="DejaVu Sans"/>
                           <a:sym typeface="DejaVu Sans"/>
                         </a:rPr>
-                        <a:t>0.045</a:t>
+                        <a:t>0.04496</a:t>
                       </a:r>
                     </a:p>
                   </a:txBody>
@@ -4739,7 +4739,7 @@
                           <a:ea typeface="DejaVu Sans"/>
                           <a:sym typeface="DejaVu Sans"/>
                         </a:rPr>
-                        <a:t>5.72</a:t>
+                        <a:t>5.717</a:t>
                       </a:r>
                     </a:p>
                   </a:txBody>
@@ -4796,7 +4796,7 @@
                           <a:ea typeface="DejaVu Sans"/>
                           <a:sym typeface="DejaVu Sans"/>
                         </a:rPr>
-                        <a:t>0.456 (0.417, 0.497)</a:t>
+                        <a:t>0.4555 (0.4171, 0.4975)</a:t>
                       </a:r>
                     </a:p>
                   </a:txBody>
@@ -4853,7 +4853,7 @@
                           <a:ea typeface="DejaVu Sans"/>
                           <a:sym typeface="DejaVu Sans"/>
                         </a:rPr>
-                        <a:t>12.7</a:t>
+                        <a:t>12.68</a:t>
                       </a:r>
                     </a:p>
                   </a:txBody>
@@ -4910,7 +4910,7 @@
                           <a:ea typeface="DejaVu Sans"/>
                           <a:sym typeface="DejaVu Sans"/>
                         </a:rPr>
-                        <a:t>13.3%&lt;</a:t>
+                        <a:t>13.29&lt;</a:t>
                       </a:r>
                     </a:p>
                   </a:txBody>
@@ -4939,7 +4939,7 @@
                   </a:tcPr>
                 </a:tc>
               </a:tr>
-              <a:tr h="406925">
+              <a:tr h="401320">
                 <a:tc>
                   <a:txBody>
                     <a:bodyPr/>
@@ -5026,7 +5026,7 @@
                           <a:ea typeface="DejaVu Sans"/>
                           <a:sym typeface="DejaVu Sans"/>
                         </a:rPr>
-                        <a:t>-3.21</a:t>
+                        <a:t>-3.215</a:t>
                       </a:r>
                     </a:p>
                   </a:txBody>
@@ -5083,7 +5083,7 @@
                           <a:ea typeface="DejaVu Sans"/>
                           <a:sym typeface="DejaVu Sans"/>
                         </a:rPr>
-                        <a:t>0.0837</a:t>
+                        <a:t>0.08374</a:t>
                       </a:r>
                     </a:p>
                   </a:txBody>
@@ -5140,7 +5140,7 @@
                           <a:ea typeface="DejaVu Sans"/>
                           <a:sym typeface="DejaVu Sans"/>
                         </a:rPr>
-                        <a:t>2.61</a:t>
+                        <a:t>2.605</a:t>
                       </a:r>
                     </a:p>
                   </a:txBody>
@@ -5197,7 +5197,7 @@
                           <a:ea typeface="DejaVu Sans"/>
                           <a:sym typeface="DejaVu Sans"/>
                         </a:rPr>
-                        <a:t>0.0402 (0.0341, 0.0473)</a:t>
+                        <a:t>0.04017 (0.03409, 0.04734)</a:t>
                       </a:r>
                     </a:p>
                   </a:txBody>
@@ -5254,7 +5254,7 @@
                           <a:ea typeface="DejaVu Sans"/>
                           <a:sym typeface="DejaVu Sans"/>
                         </a:rPr>
-                        <a:t>27.6</a:t>
+                        <a:t>27.57</a:t>
                       </a:r>
                     </a:p>
                   </a:txBody>
@@ -5311,7 +5311,7 @@
                           <a:ea typeface="DejaVu Sans"/>
                           <a:sym typeface="DejaVu Sans"/>
                         </a:rPr>
-                        <a:t>2.65%&lt;</a:t>
+                        <a:t>2.648&lt;</a:t>
                       </a:r>
                     </a:p>
                   </a:txBody>
@@ -5340,7 +5340,7 @@
                   </a:tcPr>
                 </a:tc>
               </a:tr>
-              <a:tr h="366435">
+              <a:tr h="401320">
                 <a:tc>
                   <a:txBody>
                     <a:bodyPr/>
@@ -5427,7 +5427,178 @@
                           <a:ea typeface="DejaVu Sans"/>
                           <a:sym typeface="DejaVu Sans"/>
                         </a:rPr>
-                        <a:t>0.433</a:t>
+                        <a:t>0.4333</a:t>
+                      </a:r>
+                    </a:p>
+                  </a:txBody>
+                  <a:tcPr anchor="ctr" marB="63500" marT="63500" marR="0" marL="0">
+                    <a:lnL algn="ctr" cmpd="sng" cap="flat" w="0">
+                      <a:noFill/>
+                      <a:prstDash val="solid"/>
+                    </a:lnL>
+                    <a:lnR algn="ctr" cmpd="sng" cap="flat" w="0">
+                      <a:noFill/>
+                      <a:prstDash val="solid"/>
+                    </a:lnR>
+                    <a:lnT algn="ctr" cmpd="sng" cap="flat" w="0">
+                      <a:noFill/>
+                      <a:prstDash val="solid"/>
+                    </a:lnT>
+                    <a:lnB algn="ctr" cmpd="sng" cap="flat" w="0">
+                      <a:noFill/>
+                      <a:prstDash val="solid"/>
+                    </a:lnB>
+                    <a:solidFill>
+                      <a:srgbClr val="FFFFFF">
+                        <a:alpha val="0"/>
+                      </a:srgbClr>
+                    </a:solidFill>
+                  </a:tcPr>
+                </a:tc>
+                <a:tc>
+                  <a:txBody>
+                    <a:bodyPr/>
+                    <a:lstStyle/>
+                    <a:p>
+                      <a:pPr algn="l" marL="63500" marR="63500">
+                        <a:lnSpc>
+                          <a:spcPct val="100000"/>
+                        </a:lnSpc>
+                        <a:spcBef>
+                          <a:spcPts val="500"/>
+                        </a:spcBef>
+                        <a:spcAft>
+                          <a:spcPts val="500"/>
+                        </a:spcAft>
+                        <a:buNone/>
+                      </a:pPr>
+                      <a:r>
+                        <a:rPr cap="none" sz="1100" i="0" b="0" u="none" strike="noStrike">
+                          <a:solidFill>
+                            <a:srgbClr val="000000">
+                              <a:alpha val="100000"/>
+                            </a:srgbClr>
+                          </a:solidFill>
+                          <a:latin typeface="DejaVu Sans"/>
+                          <a:cs typeface="DejaVu Sans"/>
+                          <a:ea typeface="DejaVu Sans"/>
+                          <a:sym typeface="DejaVu Sans"/>
+                        </a:rPr>
+                        <a:t>4.681e-310</a:t>
+                      </a:r>
+                    </a:p>
+                  </a:txBody>
+                  <a:tcPr anchor="ctr" marB="63500" marT="63500" marR="0" marL="0">
+                    <a:lnL algn="ctr" cmpd="sng" cap="flat" w="0">
+                      <a:noFill/>
+                      <a:prstDash val="solid"/>
+                    </a:lnL>
+                    <a:lnR algn="ctr" cmpd="sng" cap="flat" w="0">
+                      <a:noFill/>
+                      <a:prstDash val="solid"/>
+                    </a:lnR>
+                    <a:lnT algn="ctr" cmpd="sng" cap="flat" w="0">
+                      <a:noFill/>
+                      <a:prstDash val="solid"/>
+                    </a:lnT>
+                    <a:lnB algn="ctr" cmpd="sng" cap="flat" w="0">
+                      <a:noFill/>
+                      <a:prstDash val="solid"/>
+                    </a:lnB>
+                    <a:solidFill>
+                      <a:srgbClr val="FFFFFF">
+                        <a:alpha val="0"/>
+                      </a:srgbClr>
+                    </a:solidFill>
+                  </a:tcPr>
+                </a:tc>
+                <a:tc>
+                  <a:txBody>
+                    <a:bodyPr/>
+                    <a:lstStyle/>
+                    <a:p>
+                      <a:pPr algn="l" marL="63500" marR="63500">
+                        <a:lnSpc>
+                          <a:spcPct val="100000"/>
+                        </a:lnSpc>
+                        <a:spcBef>
+                          <a:spcPts val="500"/>
+                        </a:spcBef>
+                        <a:spcAft>
+                          <a:spcPts val="500"/>
+                        </a:spcAft>
+                        <a:buNone/>
+                      </a:pPr>
+                      <a:r>
+                        <a:rPr cap="none" sz="1100" i="0" b="0" u="none" strike="noStrike">
+                          <a:solidFill>
+                            <a:srgbClr val="000000">
+                              <a:alpha val="100000"/>
+                            </a:srgbClr>
+                          </a:solidFill>
+                          <a:latin typeface="DejaVu Sans"/>
+                          <a:cs typeface="DejaVu Sans"/>
+                          <a:ea typeface="DejaVu Sans"/>
+                          <a:sym typeface="DejaVu Sans"/>
+                        </a:rPr>
+                        <a:t>1.080e-307</a:t>
+                      </a:r>
+                    </a:p>
+                  </a:txBody>
+                  <a:tcPr anchor="ctr" marB="63500" marT="63500" marR="0" marL="0">
+                    <a:lnL algn="ctr" cmpd="sng" cap="flat" w="0">
+                      <a:noFill/>
+                      <a:prstDash val="solid"/>
+                    </a:lnL>
+                    <a:lnR algn="ctr" cmpd="sng" cap="flat" w="0">
+                      <a:noFill/>
+                      <a:prstDash val="solid"/>
+                    </a:lnR>
+                    <a:lnT algn="ctr" cmpd="sng" cap="flat" w="0">
+                      <a:noFill/>
+                      <a:prstDash val="solid"/>
+                    </a:lnT>
+                    <a:lnB algn="ctr" cmpd="sng" cap="flat" w="0">
+                      <a:noFill/>
+                      <a:prstDash val="solid"/>
+                    </a:lnB>
+                    <a:solidFill>
+                      <a:srgbClr val="FFFFFF">
+                        <a:alpha val="0"/>
+                      </a:srgbClr>
+                    </a:solidFill>
+                  </a:tcPr>
+                </a:tc>
+                <a:tc>
+                  <a:txBody>
+                    <a:bodyPr/>
+                    <a:lstStyle/>
+                    <a:p>
+                      <a:pPr algn="l" marL="63500" marR="63500">
+                        <a:lnSpc>
+                          <a:spcPct val="100000"/>
+                        </a:lnSpc>
+                        <a:spcBef>
+                          <a:spcPts val="500"/>
+                        </a:spcBef>
+                        <a:spcAft>
+                          <a:spcPts val="500"/>
+                        </a:spcAft>
+                        <a:buNone/>
+                      </a:pPr>
+                      <a:r>
+                        <a:rPr cap="none" sz="1100" i="0" b="0" u="none" strike="noStrike">
+                          <a:solidFill>
+                            <a:srgbClr val="000000">
+                              <a:alpha val="100000"/>
+                            </a:srgbClr>
+                          </a:solidFill>
+                          <a:latin typeface="DejaVu Sans"/>
+                          <a:cs typeface="DejaVu Sans"/>
+                          <a:ea typeface="DejaVu Sans"/>
+                          <a:sym typeface="DejaVu Sans"/>
+                        </a:rPr>
+                        <a:t>0.4333 (0.4333, 0.4333)</a:t>
                       </a:r>
                     </a:p>
                   </a:txBody>
@@ -5591,179 +5762,8 @@
                     </a:solidFill>
                   </a:tcPr>
                 </a:tc>
-                <a:tc>
-                  <a:txBody>
-                    <a:bodyPr/>
-                    <a:lstStyle/>
-                    <a:p>
-                      <a:pPr algn="l" marL="63500" marR="63500">
-                        <a:lnSpc>
-                          <a:spcPct val="100000"/>
-                        </a:lnSpc>
-                        <a:spcBef>
-                          <a:spcPts val="500"/>
-                        </a:spcBef>
-                        <a:spcAft>
-                          <a:spcPts val="500"/>
-                        </a:spcAft>
-                        <a:buNone/>
-                      </a:pPr>
-                      <a:r>
-                        <a:rPr cap="none" sz="1100" i="0" b="0" u="none" strike="noStrike">
-                          <a:solidFill>
-                            <a:srgbClr val="000000">
-                              <a:alpha val="100000"/>
-                            </a:srgbClr>
-                          </a:solidFill>
-                          <a:latin typeface="DejaVu Sans"/>
-                          <a:cs typeface="DejaVu Sans"/>
-                          <a:ea typeface="DejaVu Sans"/>
-                          <a:sym typeface="DejaVu Sans"/>
-                        </a:rPr>
-                        <a:t>0.433</a:t>
-                      </a:r>
-                    </a:p>
-                  </a:txBody>
-                  <a:tcPr anchor="ctr" marB="63500" marT="63500" marR="0" marL="0">
-                    <a:lnL algn="ctr" cmpd="sng" cap="flat" w="0">
-                      <a:noFill/>
-                      <a:prstDash val="solid"/>
-                    </a:lnL>
-                    <a:lnR algn="ctr" cmpd="sng" cap="flat" w="0">
-                      <a:noFill/>
-                      <a:prstDash val="solid"/>
-                    </a:lnR>
-                    <a:lnT algn="ctr" cmpd="sng" cap="flat" w="0">
-                      <a:noFill/>
-                      <a:prstDash val="solid"/>
-                    </a:lnT>
-                    <a:lnB algn="ctr" cmpd="sng" cap="flat" w="0">
-                      <a:noFill/>
-                      <a:prstDash val="solid"/>
-                    </a:lnB>
-                    <a:solidFill>
-                      <a:srgbClr val="FFFFFF">
-                        <a:alpha val="0"/>
-                      </a:srgbClr>
-                    </a:solidFill>
-                  </a:tcPr>
-                </a:tc>
-                <a:tc>
-                  <a:txBody>
-                    <a:bodyPr/>
-                    <a:lstStyle/>
-                    <a:p>
-                      <a:pPr algn="l" marL="63500" marR="63500">
-                        <a:lnSpc>
-                          <a:spcPct val="100000"/>
-                        </a:lnSpc>
-                        <a:spcBef>
-                          <a:spcPts val="500"/>
-                        </a:spcBef>
-                        <a:spcAft>
-                          <a:spcPts val="500"/>
-                        </a:spcAft>
-                        <a:buNone/>
-                      </a:pPr>
-                      <a:r>
-                        <a:rPr cap="none" sz="1100" i="0" b="0" u="none" strike="noStrike">
-                          <a:solidFill>
-                            <a:srgbClr val="000000">
-                              <a:alpha val="100000"/>
-                            </a:srgbClr>
-                          </a:solidFill>
-                          <a:latin typeface="DejaVu Sans"/>
-                          <a:cs typeface="DejaVu Sans"/>
-                          <a:ea typeface="DejaVu Sans"/>
-                          <a:sym typeface="DejaVu Sans"/>
-                        </a:rPr>
-                        <a:t> </a:t>
-                      </a:r>
-                    </a:p>
-                  </a:txBody>
-                  <a:tcPr anchor="ctr" marB="63500" marT="63500" marR="0" marL="0">
-                    <a:lnL algn="ctr" cmpd="sng" cap="flat" w="0">
-                      <a:noFill/>
-                      <a:prstDash val="solid"/>
-                    </a:lnL>
-                    <a:lnR algn="ctr" cmpd="sng" cap="flat" w="0">
-                      <a:noFill/>
-                      <a:prstDash val="solid"/>
-                    </a:lnR>
-                    <a:lnT algn="ctr" cmpd="sng" cap="flat" w="0">
-                      <a:noFill/>
-                      <a:prstDash val="solid"/>
-                    </a:lnT>
-                    <a:lnB algn="ctr" cmpd="sng" cap="flat" w="0">
-                      <a:noFill/>
-                      <a:prstDash val="solid"/>
-                    </a:lnB>
-                    <a:solidFill>
-                      <a:srgbClr val="FFFFFF">
-                        <a:alpha val="0"/>
-                      </a:srgbClr>
-                    </a:solidFill>
-                  </a:tcPr>
-                </a:tc>
-                <a:tc>
-                  <a:txBody>
-                    <a:bodyPr/>
-                    <a:lstStyle/>
-                    <a:p>
-                      <a:pPr algn="l" marL="63500" marR="63500">
-                        <a:lnSpc>
-                          <a:spcPct val="100000"/>
-                        </a:lnSpc>
-                        <a:spcBef>
-                          <a:spcPts val="500"/>
-                        </a:spcBef>
-                        <a:spcAft>
-                          <a:spcPts val="500"/>
-                        </a:spcAft>
-                        <a:buNone/>
-                      </a:pPr>
-                      <a:r>
-                        <a:rPr cap="none" sz="1100" i="0" b="0" u="none" strike="noStrike">
-                          <a:solidFill>
-                            <a:srgbClr val="000000">
-                              <a:alpha val="100000"/>
-                            </a:srgbClr>
-                          </a:solidFill>
-                          <a:latin typeface="DejaVu Sans"/>
-                          <a:cs typeface="DejaVu Sans"/>
-                          <a:ea typeface="DejaVu Sans"/>
-                          <a:sym typeface="DejaVu Sans"/>
-                        </a:rPr>
-                        <a:t> </a:t>
-                      </a:r>
-                    </a:p>
-                  </a:txBody>
-                  <a:tcPr anchor="ctr" marB="63500" marT="63500" marR="0" marL="0">
-                    <a:lnL algn="ctr" cmpd="sng" cap="flat" w="0">
-                      <a:noFill/>
-                      <a:prstDash val="solid"/>
-                    </a:lnL>
-                    <a:lnR algn="ctr" cmpd="sng" cap="flat" w="0">
-                      <a:noFill/>
-                      <a:prstDash val="solid"/>
-                    </a:lnR>
-                    <a:lnT algn="ctr" cmpd="sng" cap="flat" w="0">
-                      <a:noFill/>
-                      <a:prstDash val="solid"/>
-                    </a:lnT>
-                    <a:lnB algn="ctr" cmpd="sng" cap="flat" w="0">
-                      <a:noFill/>
-                      <a:prstDash val="solid"/>
-                    </a:lnB>
-                    <a:solidFill>
-                      <a:srgbClr val="FFFFFF">
-                        <a:alpha val="0"/>
-                      </a:srgbClr>
-                    </a:solidFill>
-                  </a:tcPr>
-                </a:tc>
               </a:tr>
-              <a:tr h="375378">
+              <a:tr h="410845">
                 <a:tc>
                   <a:txBody>
                     <a:bodyPr/>
@@ -5854,7 +5854,190 @@
                           <a:ea typeface="DejaVu Sans"/>
                           <a:sym typeface="DejaVu Sans"/>
                         </a:rPr>
-                        <a:t>0.0543</a:t>
+                        <a:t>0.05426</a:t>
+                      </a:r>
+                    </a:p>
+                  </a:txBody>
+                  <a:tcPr anchor="ctr" marB="63500" marT="63500" marR="0" marL="0">
+                    <a:lnL algn="ctr" cmpd="sng" cap="flat" w="0">
+                      <a:noFill/>
+                      <a:prstDash val="solid"/>
+                    </a:lnL>
+                    <a:lnR algn="ctr" cmpd="sng" cap="flat" w="0">
+                      <a:noFill/>
+                      <a:prstDash val="solid"/>
+                    </a:lnR>
+                    <a:lnT algn="ctr" cmpd="sng" cap="flat" w="0">
+                      <a:noFill/>
+                      <a:prstDash val="solid"/>
+                    </a:lnT>
+                    <a:lnB algn="ctr" cmpd="sng" cap="flat" w="19050">
+                      <a:solidFill>
+                        <a:srgbClr val="666666">
+                          <a:alpha val="100000"/>
+                        </a:srgbClr>
+                      </a:solidFill>
+                      <a:prstDash val="solid"/>
+                    </a:lnB>
+                    <a:solidFill>
+                      <a:srgbClr val="FFFFFF">
+                        <a:alpha val="0"/>
+                      </a:srgbClr>
+                    </a:solidFill>
+                  </a:tcPr>
+                </a:tc>
+                <a:tc>
+                  <a:txBody>
+                    <a:bodyPr/>
+                    <a:lstStyle/>
+                    <a:p>
+                      <a:pPr algn="l" marL="63500" marR="63500">
+                        <a:lnSpc>
+                          <a:spcPct val="100000"/>
+                        </a:lnSpc>
+                        <a:spcBef>
+                          <a:spcPts val="500"/>
+                        </a:spcBef>
+                        <a:spcAft>
+                          <a:spcPts val="500"/>
+                        </a:spcAft>
+                        <a:buNone/>
+                      </a:pPr>
+                      <a:r>
+                        <a:rPr cap="none" sz="1100" i="0" b="0" u="none" strike="noStrike">
+                          <a:solidFill>
+                            <a:srgbClr val="000000">
+                              <a:alpha val="100000"/>
+                            </a:srgbClr>
+                          </a:solidFill>
+                          <a:latin typeface="DejaVu Sans"/>
+                          <a:cs typeface="DejaVu Sans"/>
+                          <a:ea typeface="DejaVu Sans"/>
+                          <a:sym typeface="DejaVu Sans"/>
+                        </a:rPr>
+                        <a:t>0.007258</a:t>
+                      </a:r>
+                    </a:p>
+                  </a:txBody>
+                  <a:tcPr anchor="ctr" marB="63500" marT="63500" marR="0" marL="0">
+                    <a:lnL algn="ctr" cmpd="sng" cap="flat" w="0">
+                      <a:noFill/>
+                      <a:prstDash val="solid"/>
+                    </a:lnL>
+                    <a:lnR algn="ctr" cmpd="sng" cap="flat" w="0">
+                      <a:noFill/>
+                      <a:prstDash val="solid"/>
+                    </a:lnR>
+                    <a:lnT algn="ctr" cmpd="sng" cap="flat" w="0">
+                      <a:noFill/>
+                      <a:prstDash val="solid"/>
+                    </a:lnT>
+                    <a:lnB algn="ctr" cmpd="sng" cap="flat" w="19050">
+                      <a:solidFill>
+                        <a:srgbClr val="666666">
+                          <a:alpha val="100000"/>
+                        </a:srgbClr>
+                      </a:solidFill>
+                      <a:prstDash val="solid"/>
+                    </a:lnB>
+                    <a:solidFill>
+                      <a:srgbClr val="FFFFFF">
+                        <a:alpha val="0"/>
+                      </a:srgbClr>
+                    </a:solidFill>
+                  </a:tcPr>
+                </a:tc>
+                <a:tc>
+                  <a:txBody>
+                    <a:bodyPr/>
+                    <a:lstStyle/>
+                    <a:p>
+                      <a:pPr algn="l" marL="63500" marR="63500">
+                        <a:lnSpc>
+                          <a:spcPct val="100000"/>
+                        </a:lnSpc>
+                        <a:spcBef>
+                          <a:spcPts val="500"/>
+                        </a:spcBef>
+                        <a:spcAft>
+                          <a:spcPts val="500"/>
+                        </a:spcAft>
+                        <a:buNone/>
+                      </a:pPr>
+                      <a:r>
+                        <a:rPr cap="none" sz="1100" i="0" b="0" u="none" strike="noStrike">
+                          <a:solidFill>
+                            <a:srgbClr val="000000">
+                              <a:alpha val="100000"/>
+                            </a:srgbClr>
+                          </a:solidFill>
+                          <a:latin typeface="DejaVu Sans"/>
+                          <a:cs typeface="DejaVu Sans"/>
+                          <a:ea typeface="DejaVu Sans"/>
+                          <a:sym typeface="DejaVu Sans"/>
+                        </a:rPr>
+                        <a:t>13.38</a:t>
+                      </a:r>
+                    </a:p>
+                  </a:txBody>
+                  <a:tcPr anchor="ctr" marB="63500" marT="63500" marR="0" marL="0">
+                    <a:lnL algn="ctr" cmpd="sng" cap="flat" w="0">
+                      <a:noFill/>
+                      <a:prstDash val="solid"/>
+                    </a:lnL>
+                    <a:lnR algn="ctr" cmpd="sng" cap="flat" w="0">
+                      <a:noFill/>
+                      <a:prstDash val="solid"/>
+                    </a:lnR>
+                    <a:lnT algn="ctr" cmpd="sng" cap="flat" w="0">
+                      <a:noFill/>
+                      <a:prstDash val="solid"/>
+                    </a:lnT>
+                    <a:lnB algn="ctr" cmpd="sng" cap="flat" w="19050">
+                      <a:solidFill>
+                        <a:srgbClr val="666666">
+                          <a:alpha val="100000"/>
+                        </a:srgbClr>
+                      </a:solidFill>
+                      <a:prstDash val="solid"/>
+                    </a:lnB>
+                    <a:solidFill>
+                      <a:srgbClr val="FFFFFF">
+                        <a:alpha val="0"/>
+                      </a:srgbClr>
+                    </a:solidFill>
+                  </a:tcPr>
+                </a:tc>
+                <a:tc>
+                  <a:txBody>
+                    <a:bodyPr/>
+                    <a:lstStyle/>
+                    <a:p>
+                      <a:pPr algn="l" marL="63500" marR="63500">
+                        <a:lnSpc>
+                          <a:spcPct val="100000"/>
+                        </a:lnSpc>
+                        <a:spcBef>
+                          <a:spcPts val="500"/>
+                        </a:spcBef>
+                        <a:spcAft>
+                          <a:spcPts val="500"/>
+                        </a:spcAft>
+                        <a:buNone/>
+                      </a:pPr>
+                      <a:r>
+                        <a:rPr cap="none" sz="1100" i="0" b="0" u="none" strike="noStrike">
+                          <a:solidFill>
+                            <a:srgbClr val="000000">
+                              <a:alpha val="100000"/>
+                            </a:srgbClr>
+                          </a:solidFill>
+                          <a:latin typeface="DejaVu Sans"/>
+                          <a:cs typeface="DejaVu Sans"/>
+                          <a:ea typeface="DejaVu Sans"/>
+                          <a:sym typeface="DejaVu Sans"/>
+                        </a:rPr>
+                        <a:t>0.05426 (0.04003, 0.06849)</a:t>
                       </a:r>
                     </a:p>
                   </a:txBody>
@@ -5999,189 +6182,6 @@
                           <a:sym typeface="DejaVu Sans"/>
                         </a:rPr>
                         <a:t/>
-                      </a:r>
-                    </a:p>
-                  </a:txBody>
-                  <a:tcPr anchor="ctr" marB="63500" marT="63500" marR="0" marL="0">
-                    <a:lnL algn="ctr" cmpd="sng" cap="flat" w="0">
-                      <a:noFill/>
-                      <a:prstDash val="solid"/>
-                    </a:lnL>
-                    <a:lnR algn="ctr" cmpd="sng" cap="flat" w="0">
-                      <a:noFill/>
-                      <a:prstDash val="solid"/>
-                    </a:lnR>
-                    <a:lnT algn="ctr" cmpd="sng" cap="flat" w="0">
-                      <a:noFill/>
-                      <a:prstDash val="solid"/>
-                    </a:lnT>
-                    <a:lnB algn="ctr" cmpd="sng" cap="flat" w="19050">
-                      <a:solidFill>
-                        <a:srgbClr val="666666">
-                          <a:alpha val="100000"/>
-                        </a:srgbClr>
-                      </a:solidFill>
-                      <a:prstDash val="solid"/>
-                    </a:lnB>
-                    <a:solidFill>
-                      <a:srgbClr val="FFFFFF">
-                        <a:alpha val="0"/>
-                      </a:srgbClr>
-                    </a:solidFill>
-                  </a:tcPr>
-                </a:tc>
-                <a:tc>
-                  <a:txBody>
-                    <a:bodyPr/>
-                    <a:lstStyle/>
-                    <a:p>
-                      <a:pPr algn="l" marL="63500" marR="63500">
-                        <a:lnSpc>
-                          <a:spcPct val="100000"/>
-                        </a:lnSpc>
-                        <a:spcBef>
-                          <a:spcPts val="500"/>
-                        </a:spcBef>
-                        <a:spcAft>
-                          <a:spcPts val="500"/>
-                        </a:spcAft>
-                        <a:buNone/>
-                      </a:pPr>
-                      <a:r>
-                        <a:rPr cap="none" sz="1100" i="0" b="0" u="none" strike="noStrike">
-                          <a:solidFill>
-                            <a:srgbClr val="000000">
-                              <a:alpha val="100000"/>
-                            </a:srgbClr>
-                          </a:solidFill>
-                          <a:latin typeface="DejaVu Sans"/>
-                          <a:cs typeface="DejaVu Sans"/>
-                          <a:ea typeface="DejaVu Sans"/>
-                          <a:sym typeface="DejaVu Sans"/>
-                        </a:rPr>
-                        <a:t>0.0543</a:t>
-                      </a:r>
-                    </a:p>
-                  </a:txBody>
-                  <a:tcPr anchor="ctr" marB="63500" marT="63500" marR="0" marL="0">
-                    <a:lnL algn="ctr" cmpd="sng" cap="flat" w="0">
-                      <a:noFill/>
-                      <a:prstDash val="solid"/>
-                    </a:lnL>
-                    <a:lnR algn="ctr" cmpd="sng" cap="flat" w="0">
-                      <a:noFill/>
-                      <a:prstDash val="solid"/>
-                    </a:lnR>
-                    <a:lnT algn="ctr" cmpd="sng" cap="flat" w="0">
-                      <a:noFill/>
-                      <a:prstDash val="solid"/>
-                    </a:lnT>
-                    <a:lnB algn="ctr" cmpd="sng" cap="flat" w="19050">
-                      <a:solidFill>
-                        <a:srgbClr val="666666">
-                          <a:alpha val="100000"/>
-                        </a:srgbClr>
-                      </a:solidFill>
-                      <a:prstDash val="solid"/>
-                    </a:lnB>
-                    <a:solidFill>
-                      <a:srgbClr val="FFFFFF">
-                        <a:alpha val="0"/>
-                      </a:srgbClr>
-                    </a:solidFill>
-                  </a:tcPr>
-                </a:tc>
-                <a:tc>
-                  <a:txBody>
-                    <a:bodyPr/>
-                    <a:lstStyle/>
-                    <a:p>
-                      <a:pPr algn="l" marL="63500" marR="63500">
-                        <a:lnSpc>
-                          <a:spcPct val="100000"/>
-                        </a:lnSpc>
-                        <a:spcBef>
-                          <a:spcPts val="500"/>
-                        </a:spcBef>
-                        <a:spcAft>
-                          <a:spcPts val="500"/>
-                        </a:spcAft>
-                        <a:buNone/>
-                      </a:pPr>
-                      <a:r>
-                        <a:rPr cap="none" sz="1100" i="0" b="0" u="none" strike="noStrike">
-                          <a:solidFill>
-                            <a:srgbClr val="000000">
-                              <a:alpha val="100000"/>
-                            </a:srgbClr>
-                          </a:solidFill>
-                          <a:latin typeface="DejaVu Sans"/>
-                          <a:cs typeface="DejaVu Sans"/>
-                          <a:ea typeface="DejaVu Sans"/>
-                          <a:sym typeface="DejaVu Sans"/>
-                        </a:rPr>
-                        <a:t> </a:t>
-                      </a:r>
-                    </a:p>
-                  </a:txBody>
-                  <a:tcPr anchor="ctr" marB="63500" marT="63500" marR="0" marL="0">
-                    <a:lnL algn="ctr" cmpd="sng" cap="flat" w="0">
-                      <a:noFill/>
-                      <a:prstDash val="solid"/>
-                    </a:lnL>
-                    <a:lnR algn="ctr" cmpd="sng" cap="flat" w="0">
-                      <a:noFill/>
-                      <a:prstDash val="solid"/>
-                    </a:lnR>
-                    <a:lnT algn="ctr" cmpd="sng" cap="flat" w="0">
-                      <a:noFill/>
-                      <a:prstDash val="solid"/>
-                    </a:lnT>
-                    <a:lnB algn="ctr" cmpd="sng" cap="flat" w="19050">
-                      <a:solidFill>
-                        <a:srgbClr val="666666">
-                          <a:alpha val="100000"/>
-                        </a:srgbClr>
-                      </a:solidFill>
-                      <a:prstDash val="solid"/>
-                    </a:lnB>
-                    <a:solidFill>
-                      <a:srgbClr val="FFFFFF">
-                        <a:alpha val="0"/>
-                      </a:srgbClr>
-                    </a:solidFill>
-                  </a:tcPr>
-                </a:tc>
-                <a:tc>
-                  <a:txBody>
-                    <a:bodyPr/>
-                    <a:lstStyle/>
-                    <a:p>
-                      <a:pPr algn="l" marL="63500" marR="63500">
-                        <a:lnSpc>
-                          <a:spcPct val="100000"/>
-                        </a:lnSpc>
-                        <a:spcBef>
-                          <a:spcPts val="500"/>
-                        </a:spcBef>
-                        <a:spcAft>
-                          <a:spcPts val="500"/>
-                        </a:spcAft>
-                        <a:buNone/>
-                      </a:pPr>
-                      <a:r>
-                        <a:rPr cap="none" sz="1100" i="0" b="0" u="none" strike="noStrike">
-                          <a:solidFill>
-                            <a:srgbClr val="000000">
-                              <a:alpha val="100000"/>
-                            </a:srgbClr>
-                          </a:solidFill>
-                          <a:latin typeface="DejaVu Sans"/>
-                          <a:cs typeface="DejaVu Sans"/>
-                          <a:ea typeface="DejaVu Sans"/>
-                          <a:sym typeface="DejaVu Sans"/>
-                        </a:rPr>
-                        <a:t> </a:t>
                       </a:r>
                     </a:p>
                   </a:txBody>

</xml_diff>

<commit_message>
Deploying to gh-pages from @ nlmixr2/monolix2rx@d39cf0c23e0211e305839e9262e14e9bfaae2da5 🚀
</commit_message>
<xml_diff>
--- a/articles/mod-PowerPoint.pptx
+++ b/articles/mod-PowerPoint.pptx
@@ -3674,8 +3674,8 @@
               <a:tblGrid>
                 <a:gridCol w="993857"/>
                 <a:gridCol w="838468"/>
-                <a:gridCol w="1063707"/>
-                <a:gridCol w="1063707"/>
+                <a:gridCol w="838468"/>
+                <a:gridCol w="667527"/>
                 <a:gridCol w="2236082"/>
                 <a:gridCol w="975713"/>
                 <a:gridCol w="1141675"/>
@@ -5428,177 +5428,6 @@
                           <a:sym typeface="DejaVu Sans"/>
                         </a:rPr>
                         <a:t>0.4333</a:t>
-                      </a:r>
-                    </a:p>
-                  </a:txBody>
-                  <a:tcPr anchor="ctr" marB="63500" marT="63500" marR="0" marL="0">
-                    <a:lnL algn="ctr" cmpd="sng" cap="flat" w="0">
-                      <a:noFill/>
-                      <a:prstDash val="solid"/>
-                    </a:lnL>
-                    <a:lnR algn="ctr" cmpd="sng" cap="flat" w="0">
-                      <a:noFill/>
-                      <a:prstDash val="solid"/>
-                    </a:lnR>
-                    <a:lnT algn="ctr" cmpd="sng" cap="flat" w="0">
-                      <a:noFill/>
-                      <a:prstDash val="solid"/>
-                    </a:lnT>
-                    <a:lnB algn="ctr" cmpd="sng" cap="flat" w="0">
-                      <a:noFill/>
-                      <a:prstDash val="solid"/>
-                    </a:lnB>
-                    <a:solidFill>
-                      <a:srgbClr val="FFFFFF">
-                        <a:alpha val="0"/>
-                      </a:srgbClr>
-                    </a:solidFill>
-                  </a:tcPr>
-                </a:tc>
-                <a:tc>
-                  <a:txBody>
-                    <a:bodyPr/>
-                    <a:lstStyle/>
-                    <a:p>
-                      <a:pPr algn="l" marL="63500" marR="63500">
-                        <a:lnSpc>
-                          <a:spcPct val="100000"/>
-                        </a:lnSpc>
-                        <a:spcBef>
-                          <a:spcPts val="500"/>
-                        </a:spcBef>
-                        <a:spcAft>
-                          <a:spcPts val="500"/>
-                        </a:spcAft>
-                        <a:buNone/>
-                      </a:pPr>
-                      <a:r>
-                        <a:rPr cap="none" sz="1100" i="0" b="0" u="none" strike="noStrike">
-                          <a:solidFill>
-                            <a:srgbClr val="000000">
-                              <a:alpha val="100000"/>
-                            </a:srgbClr>
-                          </a:solidFill>
-                          <a:latin typeface="DejaVu Sans"/>
-                          <a:cs typeface="DejaVu Sans"/>
-                          <a:ea typeface="DejaVu Sans"/>
-                          <a:sym typeface="DejaVu Sans"/>
-                        </a:rPr>
-                        <a:t>4.681e-310</a:t>
-                      </a:r>
-                    </a:p>
-                  </a:txBody>
-                  <a:tcPr anchor="ctr" marB="63500" marT="63500" marR="0" marL="0">
-                    <a:lnL algn="ctr" cmpd="sng" cap="flat" w="0">
-                      <a:noFill/>
-                      <a:prstDash val="solid"/>
-                    </a:lnL>
-                    <a:lnR algn="ctr" cmpd="sng" cap="flat" w="0">
-                      <a:noFill/>
-                      <a:prstDash val="solid"/>
-                    </a:lnR>
-                    <a:lnT algn="ctr" cmpd="sng" cap="flat" w="0">
-                      <a:noFill/>
-                      <a:prstDash val="solid"/>
-                    </a:lnT>
-                    <a:lnB algn="ctr" cmpd="sng" cap="flat" w="0">
-                      <a:noFill/>
-                      <a:prstDash val="solid"/>
-                    </a:lnB>
-                    <a:solidFill>
-                      <a:srgbClr val="FFFFFF">
-                        <a:alpha val="0"/>
-                      </a:srgbClr>
-                    </a:solidFill>
-                  </a:tcPr>
-                </a:tc>
-                <a:tc>
-                  <a:txBody>
-                    <a:bodyPr/>
-                    <a:lstStyle/>
-                    <a:p>
-                      <a:pPr algn="l" marL="63500" marR="63500">
-                        <a:lnSpc>
-                          <a:spcPct val="100000"/>
-                        </a:lnSpc>
-                        <a:spcBef>
-                          <a:spcPts val="500"/>
-                        </a:spcBef>
-                        <a:spcAft>
-                          <a:spcPts val="500"/>
-                        </a:spcAft>
-                        <a:buNone/>
-                      </a:pPr>
-                      <a:r>
-                        <a:rPr cap="none" sz="1100" i="0" b="0" u="none" strike="noStrike">
-                          <a:solidFill>
-                            <a:srgbClr val="000000">
-                              <a:alpha val="100000"/>
-                            </a:srgbClr>
-                          </a:solidFill>
-                          <a:latin typeface="DejaVu Sans"/>
-                          <a:cs typeface="DejaVu Sans"/>
-                          <a:ea typeface="DejaVu Sans"/>
-                          <a:sym typeface="DejaVu Sans"/>
-                        </a:rPr>
-                        <a:t>1.080e-307</a:t>
-                      </a:r>
-                    </a:p>
-                  </a:txBody>
-                  <a:tcPr anchor="ctr" marB="63500" marT="63500" marR="0" marL="0">
-                    <a:lnL algn="ctr" cmpd="sng" cap="flat" w="0">
-                      <a:noFill/>
-                      <a:prstDash val="solid"/>
-                    </a:lnL>
-                    <a:lnR algn="ctr" cmpd="sng" cap="flat" w="0">
-                      <a:noFill/>
-                      <a:prstDash val="solid"/>
-                    </a:lnR>
-                    <a:lnT algn="ctr" cmpd="sng" cap="flat" w="0">
-                      <a:noFill/>
-                      <a:prstDash val="solid"/>
-                    </a:lnT>
-                    <a:lnB algn="ctr" cmpd="sng" cap="flat" w="0">
-                      <a:noFill/>
-                      <a:prstDash val="solid"/>
-                    </a:lnB>
-                    <a:solidFill>
-                      <a:srgbClr val="FFFFFF">
-                        <a:alpha val="0"/>
-                      </a:srgbClr>
-                    </a:solidFill>
-                  </a:tcPr>
-                </a:tc>
-                <a:tc>
-                  <a:txBody>
-                    <a:bodyPr/>
-                    <a:lstStyle/>
-                    <a:p>
-                      <a:pPr algn="l" marL="63500" marR="63500">
-                        <a:lnSpc>
-                          <a:spcPct val="100000"/>
-                        </a:lnSpc>
-                        <a:spcBef>
-                          <a:spcPts val="500"/>
-                        </a:spcBef>
-                        <a:spcAft>
-                          <a:spcPts val="500"/>
-                        </a:spcAft>
-                        <a:buNone/>
-                      </a:pPr>
-                      <a:r>
-                        <a:rPr cap="none" sz="1100" i="0" b="0" u="none" strike="noStrike">
-                          <a:solidFill>
-                            <a:srgbClr val="000000">
-                              <a:alpha val="100000"/>
-                            </a:srgbClr>
-                          </a:solidFill>
-                          <a:latin typeface="DejaVu Sans"/>
-                          <a:cs typeface="DejaVu Sans"/>
-                          <a:ea typeface="DejaVu Sans"/>
-                          <a:sym typeface="DejaVu Sans"/>
-                        </a:rPr>
-                        <a:t>0.4333 (0.4333, 0.4333)</a:t>
                       </a:r>
                     </a:p>
                   </a:txBody>
@@ -5762,6 +5591,199 @@
                     </a:solidFill>
                   </a:tcPr>
                 </a:tc>
+                <a:tc>
+                  <a:txBody>
+                    <a:bodyPr/>
+                    <a:lstStyle/>
+                    <a:p>
+                      <a:pPr algn="l" marL="63500" marR="63500">
+                        <a:lnSpc>
+                          <a:spcPct val="100000"/>
+                        </a:lnSpc>
+                        <a:spcBef>
+                          <a:spcPts val="500"/>
+                        </a:spcBef>
+                        <a:spcAft>
+                          <a:spcPts val="500"/>
+                        </a:spcAft>
+                        <a:buNone/>
+                      </a:pPr>
+                      <a:r>
+                        <a:rPr cap="none" sz="1100" i="0" b="0" u="none" strike="noStrike">
+                          <a:solidFill>
+                            <a:srgbClr val="000000">
+                              <a:alpha val="100000"/>
+                            </a:srgbClr>
+                          </a:solidFill>
+                          <a:latin typeface="DejaVu Sans"/>
+                          <a:cs typeface="DejaVu Sans"/>
+                          <a:ea typeface="DejaVu Sans"/>
+                          <a:sym typeface="DejaVu Sans"/>
+                        </a:rPr>
+                        <a:t>0.4333</a:t>
+                      </a:r>
+                    </a:p>
+                  </a:txBody>
+                  <a:tcPr anchor="ctr" marB="63500" marT="63500" marR="0" marL="0">
+                    <a:lnL algn="ctr" cmpd="sng" cap="flat" w="0">
+                      <a:noFill/>
+                      <a:prstDash val="solid"/>
+                    </a:lnL>
+                    <a:lnR algn="ctr" cmpd="sng" cap="flat" w="0">
+                      <a:noFill/>
+                      <a:prstDash val="solid"/>
+                    </a:lnR>
+                    <a:lnT algn="ctr" cmpd="sng" cap="flat" w="0">
+                      <a:noFill/>
+                      <a:prstDash val="solid"/>
+                    </a:lnT>
+                    <a:lnB algn="ctr" cmpd="sng" cap="flat" w="0">
+                      <a:noFill/>
+                      <a:prstDash val="solid"/>
+                    </a:lnB>
+                    <a:solidFill>
+                      <a:srgbClr val="FFFFFF">
+                        <a:alpha val="0"/>
+                      </a:srgbClr>
+                    </a:solidFill>
+                  </a:tcPr>
+                </a:tc>
+                <a:tc>
+                  <a:txBody>
+                    <a:bodyPr/>
+                    <a:lstStyle/>
+                    <a:p>
+                      <a:pPr algn="l" marL="63500" marR="63500">
+                        <a:lnSpc>
+                          <a:spcPct val="100000"/>
+                        </a:lnSpc>
+                        <a:spcBef>
+                          <a:spcPts val="500"/>
+                        </a:spcBef>
+                        <a:spcAft>
+                          <a:spcPts val="500"/>
+                        </a:spcAft>
+                        <a:buNone/>
+                      </a:pPr>
+                      <a:endParaRPr cap="none" sz="1100" i="0" b="0" u="none" strike="noStrike">
+                        <a:solidFill>
+                          <a:srgbClr val="000000">
+                            <a:alpha val="100000"/>
+                          </a:srgbClr>
+                        </a:solidFill>
+                        <a:latin typeface="DejaVu Sans"/>
+                        <a:cs typeface="DejaVu Sans"/>
+                        <a:ea typeface="DejaVu Sans"/>
+                        <a:sym typeface="DejaVu Sans"/>
+                      </a:endParaRPr>
+                      <a:r>
+                        <a:rPr cap="none" sz="1100" i="0" b="0" u="none" strike="noStrike">
+                          <a:solidFill>
+                            <a:srgbClr val="000000">
+                              <a:alpha val="100000"/>
+                            </a:srgbClr>
+                          </a:solidFill>
+                          <a:latin typeface="DejaVu Sans"/>
+                          <a:cs typeface="DejaVu Sans"/>
+                          <a:ea typeface="DejaVu Sans"/>
+                          <a:sym typeface="DejaVu Sans"/>
+                        </a:rPr>
+                        <a:t/>
+                      </a:r>
+                    </a:p>
+                  </a:txBody>
+                  <a:tcPr anchor="ctr" marB="63500" marT="63500" marR="0" marL="0">
+                    <a:lnL algn="ctr" cmpd="sng" cap="flat" w="0">
+                      <a:noFill/>
+                      <a:prstDash val="solid"/>
+                    </a:lnL>
+                    <a:lnR algn="ctr" cmpd="sng" cap="flat" w="0">
+                      <a:noFill/>
+                      <a:prstDash val="solid"/>
+                    </a:lnR>
+                    <a:lnT algn="ctr" cmpd="sng" cap="flat" w="0">
+                      <a:noFill/>
+                      <a:prstDash val="solid"/>
+                    </a:lnT>
+                    <a:lnB algn="ctr" cmpd="sng" cap="flat" w="0">
+                      <a:noFill/>
+                      <a:prstDash val="solid"/>
+                    </a:lnB>
+                    <a:solidFill>
+                      <a:srgbClr val="FFFFFF">
+                        <a:alpha val="0"/>
+                      </a:srgbClr>
+                    </a:solidFill>
+                  </a:tcPr>
+                </a:tc>
+                <a:tc>
+                  <a:txBody>
+                    <a:bodyPr/>
+                    <a:lstStyle/>
+                    <a:p>
+                      <a:pPr algn="l" marL="63500" marR="63500">
+                        <a:lnSpc>
+                          <a:spcPct val="100000"/>
+                        </a:lnSpc>
+                        <a:spcBef>
+                          <a:spcPts val="500"/>
+                        </a:spcBef>
+                        <a:spcAft>
+                          <a:spcPts val="500"/>
+                        </a:spcAft>
+                        <a:buNone/>
+                      </a:pPr>
+                      <a:endParaRPr cap="none" sz="1100" i="0" b="0" u="none" strike="noStrike">
+                        <a:solidFill>
+                          <a:srgbClr val="000000">
+                            <a:alpha val="100000"/>
+                          </a:srgbClr>
+                        </a:solidFill>
+                        <a:latin typeface="DejaVu Sans"/>
+                        <a:cs typeface="DejaVu Sans"/>
+                        <a:ea typeface="DejaVu Sans"/>
+                        <a:sym typeface="DejaVu Sans"/>
+                      </a:endParaRPr>
+                      <a:r>
+                        <a:rPr cap="none" sz="1100" i="0" b="0" u="none" strike="noStrike">
+                          <a:solidFill>
+                            <a:srgbClr val="000000">
+                              <a:alpha val="100000"/>
+                            </a:srgbClr>
+                          </a:solidFill>
+                          <a:latin typeface="DejaVu Sans"/>
+                          <a:cs typeface="DejaVu Sans"/>
+                          <a:ea typeface="DejaVu Sans"/>
+                          <a:sym typeface="DejaVu Sans"/>
+                        </a:rPr>
+                        <a:t/>
+                      </a:r>
+                    </a:p>
+                  </a:txBody>
+                  <a:tcPr anchor="ctr" marB="63500" marT="63500" marR="0" marL="0">
+                    <a:lnL algn="ctr" cmpd="sng" cap="flat" w="0">
+                      <a:noFill/>
+                      <a:prstDash val="solid"/>
+                    </a:lnL>
+                    <a:lnR algn="ctr" cmpd="sng" cap="flat" w="0">
+                      <a:noFill/>
+                      <a:prstDash val="solid"/>
+                    </a:lnR>
+                    <a:lnT algn="ctr" cmpd="sng" cap="flat" w="0">
+                      <a:noFill/>
+                      <a:prstDash val="solid"/>
+                    </a:lnT>
+                    <a:lnB algn="ctr" cmpd="sng" cap="flat" w="0">
+                      <a:noFill/>
+                      <a:prstDash val="solid"/>
+                    </a:lnB>
+                    <a:solidFill>
+                      <a:srgbClr val="FFFFFF">
+                        <a:alpha val="0"/>
+                      </a:srgbClr>
+                    </a:solidFill>
+                  </a:tcPr>
+                </a:tc>
               </a:tr>
               <a:tr h="410845">
                 <a:tc>
@@ -5903,6 +5925,17 @@
                         </a:spcAft>
                         <a:buNone/>
                       </a:pPr>
+                      <a:endParaRPr cap="none" sz="1100" i="0" b="0" u="none" strike="noStrike">
+                        <a:solidFill>
+                          <a:srgbClr val="000000">
+                            <a:alpha val="100000"/>
+                          </a:srgbClr>
+                        </a:solidFill>
+                        <a:latin typeface="DejaVu Sans"/>
+                        <a:cs typeface="DejaVu Sans"/>
+                        <a:ea typeface="DejaVu Sans"/>
+                        <a:sym typeface="DejaVu Sans"/>
+                      </a:endParaRPr>
                       <a:r>
                         <a:rPr cap="none" sz="1100" i="0" b="0" u="none" strike="noStrike">
                           <a:solidFill>
@@ -5915,7 +5948,7 @@
                           <a:ea typeface="DejaVu Sans"/>
                           <a:sym typeface="DejaVu Sans"/>
                         </a:rPr>
-                        <a:t>0.007258</a:t>
+                        <a:t/>
                       </a:r>
                     </a:p>
                   </a:txBody>
@@ -5964,6 +5997,17 @@
                         </a:spcAft>
                         <a:buNone/>
                       </a:pPr>
+                      <a:endParaRPr cap="none" sz="1100" i="0" b="0" u="none" strike="noStrike">
+                        <a:solidFill>
+                          <a:srgbClr val="000000">
+                            <a:alpha val="100000"/>
+                          </a:srgbClr>
+                        </a:solidFill>
+                        <a:latin typeface="DejaVu Sans"/>
+                        <a:cs typeface="DejaVu Sans"/>
+                        <a:ea typeface="DejaVu Sans"/>
+                        <a:sym typeface="DejaVu Sans"/>
+                      </a:endParaRPr>
                       <a:r>
                         <a:rPr cap="none" sz="1100" i="0" b="0" u="none" strike="noStrike">
                           <a:solidFill>
@@ -5976,7 +6020,7 @@
                           <a:ea typeface="DejaVu Sans"/>
                           <a:sym typeface="DejaVu Sans"/>
                         </a:rPr>
-                        <a:t>13.38</a:t>
+                        <a:t/>
                       </a:r>
                     </a:p>
                   </a:txBody>
@@ -6037,7 +6081,7 @@
                           <a:ea typeface="DejaVu Sans"/>
                           <a:sym typeface="DejaVu Sans"/>
                         </a:rPr>
-                        <a:t>0.05426 (0.04003, 0.06849)</a:t>
+                        <a:t>0.05426</a:t>
                       </a:r>
                     </a:p>
                   </a:txBody>

</xml_diff>

<commit_message>
Deploying to gh-pages from @ nlmixr2/monolix2rx@6e9d277d7cd08b87dedf810c2607bd777f0e7414 🚀
</commit_message>
<xml_diff>
--- a/articles/mod-PowerPoint.pptx
+++ b/articles/mod-PowerPoint.pptx
@@ -3673,10 +3673,10 @@
               <a:tblPr/>
               <a:tblGrid>
                 <a:gridCol w="993857"/>
-                <a:gridCol w="838468"/>
-                <a:gridCol w="838468"/>
+                <a:gridCol w="749587"/>
+                <a:gridCol w="749587"/>
                 <a:gridCol w="667527"/>
-                <a:gridCol w="2236082"/>
+                <a:gridCol w="2070530"/>
                 <a:gridCol w="975713"/>
                 <a:gridCol w="1141675"/>
               </a:tblGrid>
@@ -4224,7 +4224,7 @@
                           <a:ea typeface="DejaVu Sans"/>
                           <a:sym typeface="DejaVu Sans"/>
                         </a:rPr>
-                        <a:t>0.4270</a:t>
+                        <a:t>0.427</a:t>
                       </a:r>
                     </a:p>
                   </a:txBody>
@@ -4281,7 +4281,7 @@
                           <a:ea typeface="DejaVu Sans"/>
                           <a:sym typeface="DejaVu Sans"/>
                         </a:rPr>
-                        <a:t>0.2041</a:t>
+                        <a:t>0.204</a:t>
                       </a:r>
                     </a:p>
                   </a:txBody>
@@ -4338,7 +4338,7 @@
                           <a:ea typeface="DejaVu Sans"/>
                           <a:sym typeface="DejaVu Sans"/>
                         </a:rPr>
-                        <a:t>47.80</a:t>
+                        <a:t>47.8</a:t>
                       </a:r>
                     </a:p>
                   </a:txBody>
@@ -4395,7 +4395,7 @@
                           <a:ea typeface="DejaVu Sans"/>
                           <a:sym typeface="DejaVu Sans"/>
                         </a:rPr>
-                        <a:t>1.533 (1.027, 2.286)</a:t>
+                        <a:t>1.53 (1.03, 2.29)</a:t>
                       </a:r>
                     </a:p>
                   </a:txBody>
@@ -4452,7 +4452,7 @@
                           <a:ea typeface="DejaVu Sans"/>
                           <a:sym typeface="DejaVu Sans"/>
                         </a:rPr>
-                        <a:t>75.42</a:t>
+                        <a:t>75.4</a:t>
                       </a:r>
                     </a:p>
                   </a:txBody>
@@ -4509,7 +4509,7 @@
                           <a:ea typeface="DejaVu Sans"/>
                           <a:sym typeface="DejaVu Sans"/>
                         </a:rPr>
-                        <a:t>1.055&lt;</a:t>
+                        <a:t>1.05&lt;</a:t>
                       </a:r>
                     </a:p>
                   </a:txBody>
@@ -4625,7 +4625,7 @@
                           <a:ea typeface="DejaVu Sans"/>
                           <a:sym typeface="DejaVu Sans"/>
                         </a:rPr>
-                        <a:t>-0.7864</a:t>
+                        <a:t>-0.786</a:t>
                       </a:r>
                     </a:p>
                   </a:txBody>
@@ -4682,7 +4682,7 @@
                           <a:ea typeface="DejaVu Sans"/>
                           <a:sym typeface="DejaVu Sans"/>
                         </a:rPr>
-                        <a:t>0.04496</a:t>
+                        <a:t>0.0450</a:t>
                       </a:r>
                     </a:p>
                   </a:txBody>
@@ -4739,7 +4739,7 @@
                           <a:ea typeface="DejaVu Sans"/>
                           <a:sym typeface="DejaVu Sans"/>
                         </a:rPr>
-                        <a:t>5.717</a:t>
+                        <a:t>5.72</a:t>
                       </a:r>
                     </a:p>
                   </a:txBody>
@@ -4796,7 +4796,7 @@
                           <a:ea typeface="DejaVu Sans"/>
                           <a:sym typeface="DejaVu Sans"/>
                         </a:rPr>
-                        <a:t>0.4555 (0.4171, 0.4975)</a:t>
+                        <a:t>0.456 (0.417, 0.497)</a:t>
                       </a:r>
                     </a:p>
                   </a:txBody>
@@ -4853,7 +4853,7 @@
                           <a:ea typeface="DejaVu Sans"/>
                           <a:sym typeface="DejaVu Sans"/>
                         </a:rPr>
-                        <a:t>12.68</a:t>
+                        <a:t>12.7</a:t>
                       </a:r>
                     </a:p>
                   </a:txBody>
@@ -4910,7 +4910,7 @@
                           <a:ea typeface="DejaVu Sans"/>
                           <a:sym typeface="DejaVu Sans"/>
                         </a:rPr>
-                        <a:t>13.29&lt;</a:t>
+                        <a:t>13.3&lt;</a:t>
                       </a:r>
                     </a:p>
                   </a:txBody>
@@ -5026,7 +5026,7 @@
                           <a:ea typeface="DejaVu Sans"/>
                           <a:sym typeface="DejaVu Sans"/>
                         </a:rPr>
-                        <a:t>-3.215</a:t>
+                        <a:t>-3.21</a:t>
                       </a:r>
                     </a:p>
                   </a:txBody>
@@ -5083,7 +5083,7 @@
                           <a:ea typeface="DejaVu Sans"/>
                           <a:sym typeface="DejaVu Sans"/>
                         </a:rPr>
-                        <a:t>0.08374</a:t>
+                        <a:t>0.0837</a:t>
                       </a:r>
                     </a:p>
                   </a:txBody>
@@ -5140,7 +5140,7 @@
                           <a:ea typeface="DejaVu Sans"/>
                           <a:sym typeface="DejaVu Sans"/>
                         </a:rPr>
-                        <a:t>2.605</a:t>
+                        <a:t>2.61</a:t>
                       </a:r>
                     </a:p>
                   </a:txBody>
@@ -5197,7 +5197,7 @@
                           <a:ea typeface="DejaVu Sans"/>
                           <a:sym typeface="DejaVu Sans"/>
                         </a:rPr>
-                        <a:t>0.04017 (0.03409, 0.04734)</a:t>
+                        <a:t>0.0402 (0.0341, 0.0473)</a:t>
                       </a:r>
                     </a:p>
                   </a:txBody>
@@ -5254,7 +5254,7 @@
                           <a:ea typeface="DejaVu Sans"/>
                           <a:sym typeface="DejaVu Sans"/>
                         </a:rPr>
-                        <a:t>27.57</a:t>
+                        <a:t>27.6</a:t>
                       </a:r>
                     </a:p>
                   </a:txBody>
@@ -5311,7 +5311,7 @@
                           <a:ea typeface="DejaVu Sans"/>
                           <a:sym typeface="DejaVu Sans"/>
                         </a:rPr>
-                        <a:t>2.648&lt;</a:t>
+                        <a:t>2.65&lt;</a:t>
                       </a:r>
                     </a:p>
                   </a:txBody>
@@ -5427,7 +5427,7 @@
                           <a:ea typeface="DejaVu Sans"/>
                           <a:sym typeface="DejaVu Sans"/>
                         </a:rPr>
-                        <a:t>0.4333</a:t>
+                        <a:t>0.433</a:t>
                       </a:r>
                     </a:p>
                   </a:txBody>
@@ -5620,7 +5620,7 @@
                           <a:ea typeface="DejaVu Sans"/>
                           <a:sym typeface="DejaVu Sans"/>
                         </a:rPr>
-                        <a:t>0.4333</a:t>
+                        <a:t>0.433</a:t>
                       </a:r>
                     </a:p>
                   </a:txBody>
@@ -5876,7 +5876,7 @@
                           <a:ea typeface="DejaVu Sans"/>
                           <a:sym typeface="DejaVu Sans"/>
                         </a:rPr>
-                        <a:t>0.05426</a:t>
+                        <a:t>0.0543</a:t>
                       </a:r>
                     </a:p>
                   </a:txBody>
@@ -6081,7 +6081,7 @@
                           <a:ea typeface="DejaVu Sans"/>
                           <a:sym typeface="DejaVu Sans"/>
                         </a:rPr>
-                        <a:t>0.05426</a:t>
+                        <a:t>0.0543</a:t>
                       </a:r>
                     </a:p>
                   </a:txBody>

</xml_diff>